<commit_message>
feat(presentation): mejorar diapositivas con principios de diseño de skills (double-bezel, notas de orador y micro-interacciones)
</commit_message>
<xml_diff>
--- a/assets/docs/PK-Bayes_Presentacion_Clinica_Institucional.pptx
+++ b/assets/docs/PK-Bayes_Presentacion_Clinica_Institucional.pptx
@@ -4679,9 +4679,54 @@
           </a:p>
         </p:txBody>
       </p:sp>
+      <p:sp>
+        <p:nvSpPr>
+          <p:cNvPr id="6" name="Rounded Rectangle 5"/>
+          <p:cNvSpPr/>
+          <p:nvPr/>
+        </p:nvSpPr>
+        <p:spPr>
+          <a:xfrm>
+            <a:off x="6163056" y="1728216"/>
+            <a:ext cx="5321808" cy="4498848"/>
+          </a:xfrm>
+          <a:prstGeom prst="roundRect">
+            <a:avLst/>
+          </a:prstGeom>
+          <a:solidFill>
+            <a:srgbClr val="F1F5F9"/>
+          </a:solidFill>
+          <a:ln w="12700">
+            <a:solidFill>
+              <a:srgbClr val="E2E8F0"/>
+            </a:solidFill>
+          </a:ln>
+        </p:spPr>
+        <p:style>
+          <a:lnRef idx="1">
+            <a:schemeClr val="accent1"/>
+          </a:lnRef>
+          <a:fillRef idx="3">
+            <a:schemeClr val="accent1"/>
+          </a:fillRef>
+          <a:effectRef idx="2">
+            <a:schemeClr val="accent1"/>
+          </a:effectRef>
+          <a:fontRef idx="minor">
+            <a:schemeClr val="lt1"/>
+          </a:fontRef>
+        </p:style>
+        <p:txBody>
+          <a:bodyPr rtlCol="0" anchor="ctr"/>
+          <a:lstStyle/>
+          <a:p>
+            <a:pPr algn="ctr"/>
+          </a:p>
+        </p:txBody>
+      </p:sp>
       <p:pic>
         <p:nvPicPr>
-          <p:cNvPr id="6" name="Picture 5" descr="09-modelo-institucional.png"/>
+          <p:cNvPr id="7" name="Picture 6" descr="09-modelo-institucional.png"/>
           <p:cNvPicPr>
             <a:picLocks noChangeAspect="1"/>
           </p:cNvPicPr>
@@ -4705,7 +4750,7 @@
       </p:pic>
       <p:sp>
         <p:nvSpPr>
-          <p:cNvPr id="7" name="TextBox 6"/>
+          <p:cNvPr id="8" name="TextBox 7"/>
           <p:cNvSpPr txBox="1"/>
           <p:nvPr/>
         </p:nvSpPr>
@@ -6539,9 +6584,54 @@
           </a:p>
         </p:txBody>
       </p:sp>
+      <p:sp>
+        <p:nvSpPr>
+          <p:cNvPr id="6" name="Rounded Rectangle 5"/>
+          <p:cNvSpPr/>
+          <p:nvPr/>
+        </p:nvSpPr>
+        <p:spPr>
+          <a:xfrm>
+            <a:off x="6071616" y="1728216"/>
+            <a:ext cx="5413248" cy="3218688"/>
+          </a:xfrm>
+          <a:prstGeom prst="roundRect">
+            <a:avLst/>
+          </a:prstGeom>
+          <a:solidFill>
+            <a:srgbClr val="F1F5F9"/>
+          </a:solidFill>
+          <a:ln w="12700">
+            <a:solidFill>
+              <a:srgbClr val="E2E8F0"/>
+            </a:solidFill>
+          </a:ln>
+        </p:spPr>
+        <p:style>
+          <a:lnRef idx="1">
+            <a:schemeClr val="accent1"/>
+          </a:lnRef>
+          <a:fillRef idx="3">
+            <a:schemeClr val="accent1"/>
+          </a:fillRef>
+          <a:effectRef idx="2">
+            <a:schemeClr val="accent1"/>
+          </a:effectRef>
+          <a:fontRef idx="minor">
+            <a:schemeClr val="lt1"/>
+          </a:fontRef>
+        </p:style>
+        <p:txBody>
+          <a:bodyPr rtlCol="0" anchor="ctr"/>
+          <a:lstStyle/>
+          <a:p>
+            <a:pPr algn="ctr"/>
+          </a:p>
+        </p:txBody>
+      </p:sp>
       <p:pic>
         <p:nvPicPr>
-          <p:cNvPr id="6" name="Picture 5" descr="04-simulacion.png"/>
+          <p:cNvPr id="7" name="Picture 6" descr="04-simulacion.png"/>
           <p:cNvPicPr>
             <a:picLocks noChangeAspect="1"/>
           </p:cNvPicPr>
@@ -6565,7 +6655,7 @@
       </p:pic>
       <p:sp>
         <p:nvSpPr>
-          <p:cNvPr id="7" name="Rounded Rectangle 6"/>
+          <p:cNvPr id="8" name="Rounded Rectangle 7"/>
           <p:cNvSpPr/>
           <p:nvPr/>
         </p:nvSpPr>
@@ -6631,7 +6721,7 @@
       </p:sp>
       <p:sp>
         <p:nvSpPr>
-          <p:cNvPr id="8" name="TextBox 7"/>
+          <p:cNvPr id="9" name="TextBox 8"/>
           <p:cNvSpPr txBox="1"/>
           <p:nvPr/>
         </p:nvSpPr>
@@ -6795,9 +6885,54 @@
           </a:p>
         </p:txBody>
       </p:sp>
+      <p:sp>
+        <p:nvSpPr>
+          <p:cNvPr id="5" name="Rounded Rectangle 4"/>
+          <p:cNvSpPr/>
+          <p:nvPr/>
+        </p:nvSpPr>
+        <p:spPr>
+          <a:xfrm>
+            <a:off x="676656" y="1728216"/>
+            <a:ext cx="5596128" cy="4498848"/>
+          </a:xfrm>
+          <a:prstGeom prst="roundRect">
+            <a:avLst/>
+          </a:prstGeom>
+          <a:solidFill>
+            <a:srgbClr val="F1F5F9"/>
+          </a:solidFill>
+          <a:ln w="12700">
+            <a:solidFill>
+              <a:srgbClr val="E2E8F0"/>
+            </a:solidFill>
+          </a:ln>
+        </p:spPr>
+        <p:style>
+          <a:lnRef idx="1">
+            <a:schemeClr val="accent1"/>
+          </a:lnRef>
+          <a:fillRef idx="3">
+            <a:schemeClr val="accent1"/>
+          </a:fillRef>
+          <a:effectRef idx="2">
+            <a:schemeClr val="accent1"/>
+          </a:effectRef>
+          <a:fontRef idx="minor">
+            <a:schemeClr val="lt1"/>
+          </a:fontRef>
+        </p:style>
+        <p:txBody>
+          <a:bodyPr rtlCol="0" anchor="ctr"/>
+          <a:lstStyle/>
+          <a:p>
+            <a:pPr algn="ctr"/>
+          </a:p>
+        </p:txBody>
+      </p:sp>
       <p:pic>
         <p:nvPicPr>
-          <p:cNvPr id="5" name="Picture 4" descr="03-funcion-renal.png"/>
+          <p:cNvPr id="6" name="Picture 5" descr="03-funcion-renal.png"/>
           <p:cNvPicPr>
             <a:picLocks noChangeAspect="1"/>
           </p:cNvPicPr>
@@ -6821,7 +6956,7 @@
       </p:pic>
       <p:sp>
         <p:nvSpPr>
-          <p:cNvPr id="6" name="Rounded Rectangle 5"/>
+          <p:cNvPr id="7" name="Rounded Rectangle 6"/>
           <p:cNvSpPr/>
           <p:nvPr/>
         </p:nvSpPr>
@@ -6890,7 +7025,7 @@
       </p:sp>
       <p:sp>
         <p:nvSpPr>
-          <p:cNvPr id="7" name="Rounded Rectangle 6"/>
+          <p:cNvPr id="8" name="Rounded Rectangle 7"/>
           <p:cNvSpPr/>
           <p:nvPr/>
         </p:nvSpPr>
@@ -6959,7 +7094,7 @@
       </p:sp>
       <p:sp>
         <p:nvSpPr>
-          <p:cNvPr id="8" name="Rounded Rectangle 7"/>
+          <p:cNvPr id="9" name="Rounded Rectangle 8"/>
           <p:cNvSpPr/>
           <p:nvPr/>
         </p:nvSpPr>
@@ -7028,7 +7163,7 @@
       </p:sp>
       <p:sp>
         <p:nvSpPr>
-          <p:cNvPr id="9" name="TextBox 8"/>
+          <p:cNvPr id="10" name="TextBox 9"/>
           <p:cNvSpPr txBox="1"/>
           <p:nvPr/>
         </p:nvSpPr>
@@ -8196,9 +8331,54 @@
           </a:p>
         </p:txBody>
       </p:sp>
+      <p:sp>
+        <p:nvSpPr>
+          <p:cNvPr id="5" name="Rounded Rectangle 4"/>
+          <p:cNvSpPr/>
+          <p:nvPr/>
+        </p:nvSpPr>
+        <p:spPr>
+          <a:xfrm>
+            <a:off x="676656" y="1728216"/>
+            <a:ext cx="6327648" cy="4498848"/>
+          </a:xfrm>
+          <a:prstGeom prst="roundRect">
+            <a:avLst/>
+          </a:prstGeom>
+          <a:solidFill>
+            <a:srgbClr val="F1F5F9"/>
+          </a:solidFill>
+          <a:ln w="12700">
+            <a:solidFill>
+              <a:srgbClr val="E2E8F0"/>
+            </a:solidFill>
+          </a:ln>
+        </p:spPr>
+        <p:style>
+          <a:lnRef idx="1">
+            <a:schemeClr val="accent1"/>
+          </a:lnRef>
+          <a:fillRef idx="3">
+            <a:schemeClr val="accent1"/>
+          </a:fillRef>
+          <a:effectRef idx="2">
+            <a:schemeClr val="accent1"/>
+          </a:effectRef>
+          <a:fontRef idx="minor">
+            <a:schemeClr val="lt1"/>
+          </a:fontRef>
+        </p:style>
+        <p:txBody>
+          <a:bodyPr rtlCol="0" anchor="ctr"/>
+          <a:lstStyle/>
+          <a:p>
+            <a:pPr algn="ctr"/>
+          </a:p>
+        </p:txBody>
+      </p:sp>
       <p:pic>
         <p:nvPicPr>
-          <p:cNvPr id="5" name="Picture 4" descr="01-dashboard.png"/>
+          <p:cNvPr id="6" name="Picture 5" descr="01-dashboard.png"/>
           <p:cNvPicPr>
             <a:picLocks noChangeAspect="1"/>
           </p:cNvPicPr>
@@ -8222,7 +8402,7 @@
       </p:pic>
       <p:sp>
         <p:nvSpPr>
-          <p:cNvPr id="6" name="Rounded Rectangle 5"/>
+          <p:cNvPr id="7" name="Rounded Rectangle 6"/>
           <p:cNvSpPr/>
           <p:nvPr/>
         </p:nvSpPr>
@@ -8384,7 +8564,7 @@
       </p:sp>
       <p:sp>
         <p:nvSpPr>
-          <p:cNvPr id="7" name="TextBox 6"/>
+          <p:cNvPr id="8" name="TextBox 7"/>
           <p:cNvSpPr txBox="1"/>
           <p:nvPr/>
         </p:nvSpPr>
@@ -8710,9 +8890,54 @@
           </a:p>
         </p:txBody>
       </p:sp>
+      <p:sp>
+        <p:nvSpPr>
+          <p:cNvPr id="6" name="Rounded Rectangle 5"/>
+          <p:cNvSpPr/>
+          <p:nvPr/>
+        </p:nvSpPr>
+        <p:spPr>
+          <a:xfrm>
+            <a:off x="5705856" y="1728216"/>
+            <a:ext cx="5779008" cy="4498848"/>
+          </a:xfrm>
+          <a:prstGeom prst="roundRect">
+            <a:avLst/>
+          </a:prstGeom>
+          <a:solidFill>
+            <a:srgbClr val="F1F5F9"/>
+          </a:solidFill>
+          <a:ln w="12700">
+            <a:solidFill>
+              <a:srgbClr val="E2E8F0"/>
+            </a:solidFill>
+          </a:ln>
+        </p:spPr>
+        <p:style>
+          <a:lnRef idx="1">
+            <a:schemeClr val="accent1"/>
+          </a:lnRef>
+          <a:fillRef idx="3">
+            <a:schemeClr val="accent1"/>
+          </a:fillRef>
+          <a:effectRef idx="2">
+            <a:schemeClr val="accent1"/>
+          </a:effectRef>
+          <a:fontRef idx="minor">
+            <a:schemeClr val="lt1"/>
+          </a:fontRef>
+        </p:style>
+        <p:txBody>
+          <a:bodyPr rtlCol="0" anchor="ctr"/>
+          <a:lstStyle/>
+          <a:p>
+            <a:pPr algn="ctr"/>
+          </a:p>
+        </p:txBody>
+      </p:sp>
       <p:pic>
         <p:nvPicPr>
-          <p:cNvPr id="6" name="Picture 5" descr="04-simulacion.png"/>
+          <p:cNvPr id="7" name="Picture 6" descr="04-simulacion.png"/>
           <p:cNvPicPr>
             <a:picLocks noChangeAspect="1"/>
           </p:cNvPicPr>
@@ -8736,7 +8961,7 @@
       </p:pic>
       <p:sp>
         <p:nvSpPr>
-          <p:cNvPr id="7" name="TextBox 6"/>
+          <p:cNvPr id="8" name="TextBox 7"/>
           <p:cNvSpPr txBox="1"/>
           <p:nvPr/>
         </p:nvSpPr>

</xml_diff>